<commit_message>
updated jenkins and github actions notes
</commit_message>
<xml_diff>
--- a/05-CICD-Intro&Jenkins/05-CICD-Fundamentals.pptx
+++ b/05-CICD-Intro&Jenkins/05-CICD-Fundamentals.pptx
@@ -2968,7 +2968,21 @@
               </a:rPr>
               <a:t>What is CI/CD? The Big Picture</a:t>
             </a:r>
-            <a:endParaRPr lang="en-US" sz="3200" dirty="0"/>
+          </a:p>
+          <a:p>
+            <a:pPr marL="0" indent="0">
+              <a:buNone/>
+            </a:pPr>
+            <a:r>
+              <a:rPr lang="en-US" sz="2000" b="1" dirty="0">
+                <a:solidFill>
+                  <a:srgbClr val="283A5E"/>
+                </a:solidFill>
+                <a:latin typeface="Trebuchet MS" pitchFamily="34" charset="0"/>
+              </a:rPr>
+              <a:t>Build once – Deploy Often</a:t>
+            </a:r>
+            <a:endParaRPr lang="en-US" sz="2000" dirty="0"/>
           </a:p>
         </p:txBody>
       </p:sp>
@@ -6543,7 +6557,7 @@
         <p:spPr>
           <a:xfrm>
             <a:off x="731520" y="3337560"/>
-            <a:ext cx="4114800" cy="274320"/>
+            <a:ext cx="3124200" cy="274320"/>
           </a:xfrm>
           <a:prstGeom prst="rect">
             <a:avLst/>
@@ -6567,7 +6581,7 @@
                 <a:ea typeface="Calibri" pitchFamily="34" charset="-122"/>
                 <a:cs typeface="Calibri" pitchFamily="34" charset="-120"/>
               </a:rPr>
-              <a:t>•  Never commit to a broken main branch</a:t>
+              <a:t>•  Never commit to a broken main branch // follow proper git branching strategy</a:t>
             </a:r>
             <a:endParaRPr lang="en-US" sz="1100" dirty="0"/>
           </a:p>

</xml_diff>